<commit_message>
Update deck: surface dual-track AER, fix README.md reference
Bring the pitch deck in line with the repositioned README:

- Slide 11 (Measurement): AER now noted as measured on two parallel tracks
  (organization and customer), not just the three stages.
- Slide 4 (Value Proposition): "Prove the value" echoes the dual-track —
  AER measuring two tracks, the organization and the customer — while
  keeping the "continuously improvable" Product Mindset thread.
- Slide 13: corrected "readme.md" -> "README.md" (case-sensitive link).

Co-Authored-By: Claude Opus 4.8 (1M context) <noreply@anthropic.com>
</commit_message>
<xml_diff>
--- a/insheights-ivcs.pptx
+++ b/insheights-ivcs.pptx
@@ -272,7 +272,7 @@
           <a:p>
             <a:fld id="{48AC9599-C581-46AA-9567-7D0A9D198E55}" type="datetimeFigureOut">
               <a:rPr lang="en-US" smtClean="0"/>
-              <a:t>6/13/2026</a:t>
+              <a:t>6/15/2026</a:t>
             </a:fld>
             <a:endParaRPr lang="en-US"/>
           </a:p>
@@ -470,7 +470,7 @@
           <a:p>
             <a:fld id="{48AC9599-C581-46AA-9567-7D0A9D198E55}" type="datetimeFigureOut">
               <a:rPr lang="en-US" smtClean="0"/>
-              <a:t>6/13/2026</a:t>
+              <a:t>6/15/2026</a:t>
             </a:fld>
             <a:endParaRPr lang="en-US"/>
           </a:p>
@@ -678,7 +678,7 @@
           <a:p>
             <a:fld id="{48AC9599-C581-46AA-9567-7D0A9D198E55}" type="datetimeFigureOut">
               <a:rPr lang="en-US" smtClean="0"/>
-              <a:t>6/13/2026</a:t>
+              <a:t>6/15/2026</a:t>
             </a:fld>
             <a:endParaRPr lang="en-US"/>
           </a:p>
@@ -909,7 +909,7 @@
           <a:p>
             <a:fld id="{48AC9599-C581-46AA-9567-7D0A9D198E55}" type="datetimeFigureOut">
               <a:rPr lang="en-US" smtClean="0"/>
-              <a:t>6/13/2026</a:t>
+              <a:t>6/15/2026</a:t>
             </a:fld>
             <a:endParaRPr lang="en-US"/>
           </a:p>
@@ -1184,7 +1184,7 @@
           <a:p>
             <a:fld id="{48AC9599-C581-46AA-9567-7D0A9D198E55}" type="datetimeFigureOut">
               <a:rPr lang="en-US" smtClean="0"/>
-              <a:t>6/13/2026</a:t>
+              <a:t>6/15/2026</a:t>
             </a:fld>
             <a:endParaRPr lang="en-US"/>
           </a:p>
@@ -1449,7 +1449,7 @@
           <a:p>
             <a:fld id="{48AC9599-C581-46AA-9567-7D0A9D198E55}" type="datetimeFigureOut">
               <a:rPr lang="en-US" smtClean="0"/>
-              <a:t>6/13/2026</a:t>
+              <a:t>6/15/2026</a:t>
             </a:fld>
             <a:endParaRPr lang="en-US"/>
           </a:p>
@@ -1861,7 +1861,7 @@
           <a:p>
             <a:fld id="{48AC9599-C581-46AA-9567-7D0A9D198E55}" type="datetimeFigureOut">
               <a:rPr lang="en-US" smtClean="0"/>
-              <a:t>6/13/2026</a:t>
+              <a:t>6/15/2026</a:t>
             </a:fld>
             <a:endParaRPr lang="en-US"/>
           </a:p>
@@ -2002,7 +2002,7 @@
           <a:p>
             <a:fld id="{48AC9599-C581-46AA-9567-7D0A9D198E55}" type="datetimeFigureOut">
               <a:rPr lang="en-US" smtClean="0"/>
-              <a:t>6/13/2026</a:t>
+              <a:t>6/15/2026</a:t>
             </a:fld>
             <a:endParaRPr lang="en-US"/>
           </a:p>
@@ -2115,7 +2115,7 @@
           <a:p>
             <a:fld id="{48AC9599-C581-46AA-9567-7D0A9D198E55}" type="datetimeFigureOut">
               <a:rPr lang="en-US" smtClean="0"/>
-              <a:t>6/13/2026</a:t>
+              <a:t>6/15/2026</a:t>
             </a:fld>
             <a:endParaRPr lang="en-US"/>
           </a:p>
@@ -2426,7 +2426,7 @@
           <a:p>
             <a:fld id="{48AC9599-C581-46AA-9567-7D0A9D198E55}" type="datetimeFigureOut">
               <a:rPr lang="en-US" smtClean="0"/>
-              <a:t>6/13/2026</a:t>
+              <a:t>6/15/2026</a:t>
             </a:fld>
             <a:endParaRPr lang="en-US"/>
           </a:p>
@@ -2714,7 +2714,7 @@
           <a:p>
             <a:fld id="{48AC9599-C581-46AA-9567-7D0A9D198E55}" type="datetimeFigureOut">
               <a:rPr lang="en-US" smtClean="0"/>
-              <a:t>6/13/2026</a:t>
+              <a:t>6/15/2026</a:t>
             </a:fld>
             <a:endParaRPr lang="en-US"/>
           </a:p>
@@ -2955,7 +2955,7 @@
           <a:p>
             <a:fld id="{48AC9599-C581-46AA-9567-7D0A9D198E55}" type="datetimeFigureOut">
               <a:rPr lang="en-US" smtClean="0"/>
-              <a:t>6/13/2026</a:t>
+              <a:t>6/15/2026</a:t>
             </a:fld>
             <a:endParaRPr lang="en-US"/>
           </a:p>
@@ -5000,7 +5000,7 @@
           <a:p>
             <a:pPr algn="l"/>
             <a:r>
-              <a:rPr lang="en-US" sz="1800" b="1">
+              <a:rPr lang="en-US" sz="1800" b="1" dirty="0">
                 <a:solidFill>
                   <a:srgbClr val="1F2A66"/>
                 </a:solidFill>
@@ -5008,7 +5008,18 @@
                 <a:ea typeface="Calibri"/>
                 <a:cs typeface="Calibri"/>
               </a:rPr>
-              <a:t>AER — Adoption, Engagement, Retention</a:t>
+              <a:t>AER — Adoption, Engagement, Retention – </a:t>
+            </a:r>
+            <a:r>
+              <a:rPr lang="en-US" sz="1600" dirty="0">
+                <a:solidFill>
+                  <a:srgbClr val="1F2A66"/>
+                </a:solidFill>
+                <a:latin typeface="Calibri"/>
+                <a:ea typeface="Calibri"/>
+                <a:cs typeface="Calibri"/>
+              </a:rPr>
+              <a:t>measured on two parallel tracks: organization and customer</a:t>
             </a:r>
           </a:p>
         </p:txBody>
@@ -5876,7 +5887,7 @@
                   <a:srgbClr val="D8ECF2"/>
                 </a:solidFill>
               </a:rPr>
-              <a:t>Explore the full system – readme.md </a:t>
+              <a:t>Explore the full system – README.md </a:t>
             </a:r>
           </a:p>
           <a:p>
@@ -7251,7 +7262,7 @@
           <a:p>
             <a:pPr algn="l"/>
             <a:r>
-              <a:rPr lang="en-US" sz="1400">
+              <a:rPr lang="en-US" sz="1400" dirty="0">
                 <a:solidFill>
                   <a:srgbClr val="5A6478"/>
                 </a:solidFill>
@@ -8341,8 +8352,8 @@
         </p:nvSpPr>
         <p:spPr>
           <a:xfrm>
-            <a:off x="8183880" y="4241800"/>
-            <a:ext cx="2834640" cy="889000"/>
+            <a:off x="8183879" y="4241800"/>
+            <a:ext cx="3017521" cy="889000"/>
           </a:xfrm>
           <a:prstGeom prst="rect">
             <a:avLst/>
@@ -8357,7 +8368,7 @@
           <a:p>
             <a:pPr algn="l"/>
             <a:r>
-              <a:rPr lang="en-US" sz="1350">
+              <a:rPr lang="en-US" sz="1350" dirty="0">
                 <a:solidFill>
                   <a:srgbClr val="5A6478"/>
                 </a:solidFill>
@@ -8365,7 +8376,7 @@
                 <a:ea typeface="Calibri"/>
                 <a:cs typeface="Calibri"/>
               </a:rPr>
-              <a:t>3E, AER, and the 8 Values make value visible, measurable, and continuously improvable.</a:t>
+              <a:t>3E, AER, and the 8 Values make value visible, measurable, and continuously improvable – with AER measuring two tracks: the organization and the customer.</a:t>
             </a:r>
           </a:p>
         </p:txBody>

</xml_diff>